<commit_message>
Docs: qualify old quick start, exit-code and troubleshooting docs, demo guide, 2-slide architecture deck (main-era + full-stack)
</commit_message>
<xml_diff>
--- a/docs/architecture.pptx
+++ b/docs/architecture.pptx
@@ -6,6 +6,7 @@
   </p:sldMasterIdLst>
   <p:sldIdLst>
     <p:sldId id="256" r:id="rId7"/>
+    <p:sldId id="257" r:id="rId8"/>
   </p:sldIdLst>
   <p:sldSz cx="12191695" cy="6858000" type="screen4x3"/>
   <p:notesSz cx="6858000" cy="9144000"/>
@@ -3118,7 +3119,7 @@
                 </a:solidFill>
                 <a:latin typeface="Calibri"/>
               </a:rPr>
-              <a:t>MOSIP Inji OpenID Conformance Automation: Architecture</a:t>
+              <a:t>Original runner on main: Architecture (existing-environment view)</a:t>
             </a:r>
           </a:p>
         </p:txBody>
@@ -3147,13 +3148,13 @@
           <a:p>
             <a:pPr algn="l"/>
             <a:r>
-              <a:rPr sz="1300" b="1">
+              <a:rPr sz="1200" b="1">
                 <a:solidFill>
                   <a:srgbClr val="5B6573"/>
                 </a:solidFill>
                 <a:latin typeface="Calibri"/>
               </a:rPr>
-              <a:t>Run once, test Inji Certify (OpenID4VCI) and Inji Verify (OpenID4VP) against the OpenID Foundation Conformance Suite</a:t>
+              <a:t>Main-era view: you start Certify and Verify yourself. The full-stack path on branch e2e-full-run is on the next slide.</a:t>
             </a:r>
           </a:p>
         </p:txBody>
@@ -4456,6 +4457,1523 @@
                 <a:latin typeface="Consolas"/>
               </a:rPr>
               <a:t/>
+            </a:r>
+          </a:p>
+        </p:txBody>
+      </p:sp>
+    </p:spTree>
+  </p:cSld>
+  <p:clrMapOvr>
+    <a:masterClrMapping/>
+  </p:clrMapOvr>
+</p:sld>
+</file>
+
+<file path=ppt/slides/slide2.xml><?xml version="1.0" encoding="utf-8"?>
+<p:sld xmlns:a="http://schemas.openxmlformats.org/drawingml/2006/main" xmlns:p="http://schemas.openxmlformats.org/presentationml/2006/main" xmlns:r="http://schemas.openxmlformats.org/officeDocument/2006/relationships">
+  <p:cSld>
+    <p:spTree>
+      <p:nvGrpSpPr>
+        <p:cNvPr id="1" name=""/>
+        <p:cNvGrpSpPr/>
+        <p:nvPr/>
+      </p:nvGrpSpPr>
+      <p:grpSpPr/>
+      <p:sp>
+        <p:nvSpPr>
+          <p:cNvPr id="2" name="TextBox 1"/>
+          <p:cNvSpPr txBox="1"/>
+          <p:nvPr/>
+        </p:nvSpPr>
+        <p:spPr>
+          <a:xfrm>
+            <a:off x="457200" y="228600"/>
+            <a:ext cx="11247120" cy="548640"/>
+          </a:xfrm>
+          <a:prstGeom prst="rect">
+            <a:avLst/>
+          </a:prstGeom>
+          <a:noFill/>
+        </p:spPr>
+        <p:txBody>
+          <a:bodyPr wrap="square">
+            <a:spAutoFit/>
+          </a:bodyPr>
+          <a:lstStyle/>
+          <a:p>
+            <a:pPr algn="l"/>
+            <a:r>
+              <a:rPr sz="2600" b="1">
+                <a:solidFill>
+                  <a:srgbClr val="1F2937"/>
+                </a:solidFill>
+                <a:latin typeface="Calibri"/>
+              </a:rPr>
+              <a:t>Full-stack native run (branch e2e-full-run): Architecture</a:t>
+            </a:r>
+          </a:p>
+        </p:txBody>
+      </p:sp>
+      <p:sp>
+        <p:nvSpPr>
+          <p:cNvPr id="3" name="TextBox 2"/>
+          <p:cNvSpPr txBox="1"/>
+          <p:nvPr/>
+        </p:nvSpPr>
+        <p:spPr>
+          <a:xfrm>
+            <a:off x="457200" y="749808"/>
+            <a:ext cx="11247120" cy="365760"/>
+          </a:xfrm>
+          <a:prstGeom prst="rect">
+            <a:avLst/>
+          </a:prstGeom>
+          <a:noFill/>
+        </p:spPr>
+        <p:txBody>
+          <a:bodyPr wrap="square">
+            <a:spAutoFit/>
+          </a:bodyPr>
+          <a:lstStyle/>
+          <a:p>
+            <a:pPr algn="l"/>
+            <a:r>
+              <a:rPr sz="1300" b="1">
+                <a:solidFill>
+                  <a:srgbClr val="5B6573"/>
+                </a:solidFill>
+                <a:latin typeface="Calibri"/>
+              </a:rPr>
+              <a:t>One command boots one disposable stack and runs the selected happy-flow modules. Not full official plans, not certification.</a:t>
+            </a:r>
+          </a:p>
+        </p:txBody>
+      </p:sp>
+      <p:sp>
+        <p:nvSpPr>
+          <p:cNvPr id="4" name="Rounded Rectangle 3"/>
+          <p:cNvSpPr/>
+          <p:nvPr/>
+        </p:nvSpPr>
+        <p:spPr>
+          <a:xfrm>
+            <a:off x="365760" y="1325880"/>
+            <a:ext cx="3200400" cy="3566160"/>
+          </a:xfrm>
+          <a:prstGeom prst="roundRect">
+            <a:avLst>
+              <a:gd name="adj" fmla="val 6000"/>
+            </a:avLst>
+          </a:prstGeom>
+          <a:noFill/>
+          <a:ln w="19050">
+            <a:solidFill>
+              <a:srgbClr val="9CA3AF"/>
+            </a:solidFill>
+            <a:prstDash val="dash"/>
+          </a:ln>
+          <a:effectLst/>
+        </p:spPr>
+        <p:style>
+          <a:lnRef idx="1">
+            <a:schemeClr val="accent1"/>
+          </a:lnRef>
+          <a:fillRef idx="3">
+            <a:schemeClr val="accent1"/>
+          </a:fillRef>
+          <a:effectRef idx="2">
+            <a:schemeClr val="accent1"/>
+          </a:effectRef>
+          <a:fontRef idx="minor">
+            <a:schemeClr val="lt1"/>
+          </a:fontRef>
+        </p:style>
+        <p:txBody>
+          <a:bodyPr rtlCol="0" anchor="t" wrap="square"/>
+          <a:lstStyle/>
+          <a:p>
+            <a:pPr algn="ctr"/>
+            <a:r>
+              <a:rPr sz="1200" b="1">
+                <a:solidFill>
+                  <a:srgbClr val="5B6573"/>
+                </a:solidFill>
+                <a:latin typeface="Calibri"/>
+              </a:rPr>
+              <a:t>Host harness (CI runner or scratch Linux box)</a:t>
+            </a:r>
+          </a:p>
+        </p:txBody>
+      </p:sp>
+      <p:sp>
+        <p:nvSpPr>
+          <p:cNvPr id="5" name="Rounded Rectangle 4"/>
+          <p:cNvSpPr/>
+          <p:nvPr/>
+        </p:nvSpPr>
+        <p:spPr>
+          <a:xfrm>
+            <a:off x="4114800" y="1325880"/>
+            <a:ext cx="4023360" cy="3566160"/>
+          </a:xfrm>
+          <a:prstGeom prst="roundRect">
+            <a:avLst>
+              <a:gd name="adj" fmla="val 6000"/>
+            </a:avLst>
+          </a:prstGeom>
+          <a:noFill/>
+          <a:ln w="19050">
+            <a:solidFill>
+              <a:srgbClr val="9CA3AF"/>
+            </a:solidFill>
+            <a:prstDash val="dash"/>
+          </a:ln>
+          <a:effectLst/>
+        </p:spPr>
+        <p:style>
+          <a:lnRef idx="1">
+            <a:schemeClr val="accent1"/>
+          </a:lnRef>
+          <a:fillRef idx="3">
+            <a:schemeClr val="accent1"/>
+          </a:fillRef>
+          <a:effectRef idx="2">
+            <a:schemeClr val="accent1"/>
+          </a:effectRef>
+          <a:fontRef idx="minor">
+            <a:schemeClr val="lt1"/>
+          </a:fontRef>
+        </p:style>
+        <p:txBody>
+          <a:bodyPr rtlCol="0" anchor="t" wrap="square"/>
+          <a:lstStyle/>
+          <a:p>
+            <a:pPr algn="ctr"/>
+            <a:r>
+              <a:rPr sz="1200" b="1">
+                <a:solidFill>
+                  <a:srgbClr val="5B6573"/>
+                </a:solidFill>
+                <a:latin typeface="Calibri"/>
+              </a:rPr>
+              <a:t>One owned stack (Docker Compose, loopback)</a:t>
+            </a:r>
+          </a:p>
+        </p:txBody>
+      </p:sp>
+      <p:sp>
+        <p:nvSpPr>
+          <p:cNvPr id="6" name="Rounded Rectangle 5"/>
+          <p:cNvSpPr/>
+          <p:nvPr/>
+        </p:nvSpPr>
+        <p:spPr>
+          <a:xfrm>
+            <a:off x="8686800" y="1325880"/>
+            <a:ext cx="3139440" cy="3566160"/>
+          </a:xfrm>
+          <a:prstGeom prst="roundRect">
+            <a:avLst>
+              <a:gd name="adj" fmla="val 6000"/>
+            </a:avLst>
+          </a:prstGeom>
+          <a:noFill/>
+          <a:ln w="19050">
+            <a:solidFill>
+              <a:srgbClr val="9CA3AF"/>
+            </a:solidFill>
+            <a:prstDash val="dash"/>
+          </a:ln>
+          <a:effectLst/>
+        </p:spPr>
+        <p:style>
+          <a:lnRef idx="1">
+            <a:schemeClr val="accent1"/>
+          </a:lnRef>
+          <a:fillRef idx="3">
+            <a:schemeClr val="accent1"/>
+          </a:fillRef>
+          <a:effectRef idx="2">
+            <a:schemeClr val="accent1"/>
+          </a:effectRef>
+          <a:fontRef idx="minor">
+            <a:schemeClr val="lt1"/>
+          </a:fontRef>
+        </p:style>
+        <p:txBody>
+          <a:bodyPr rtlCol="0" anchor="t" wrap="square"/>
+          <a:lstStyle/>
+          <a:p>
+            <a:pPr algn="ctr"/>
+            <a:r>
+              <a:rPr sz="1200" b="1">
+                <a:solidFill>
+                  <a:srgbClr val="5B6573"/>
+                </a:solidFill>
+                <a:latin typeface="Calibri"/>
+              </a:rPr>
+              <a:t>Evidence (public part audited)</a:t>
+            </a:r>
+          </a:p>
+        </p:txBody>
+      </p:sp>
+      <p:sp>
+        <p:nvSpPr>
+          <p:cNvPr id="7" name="Rounded Rectangle 6"/>
+          <p:cNvSpPr/>
+          <p:nvPr/>
+        </p:nvSpPr>
+        <p:spPr>
+          <a:xfrm>
+            <a:off x="548640" y="1783080"/>
+            <a:ext cx="2834640" cy="960120"/>
+          </a:xfrm>
+          <a:prstGeom prst="roundRect">
+            <a:avLst>
+              <a:gd name="adj" fmla="val 6000"/>
+            </a:avLst>
+          </a:prstGeom>
+          <a:solidFill>
+            <a:srgbClr val="F3F4F6"/>
+          </a:solidFill>
+          <a:ln w="19050">
+            <a:solidFill>
+              <a:srgbClr val="6B7280"/>
+            </a:solidFill>
+          </a:ln>
+          <a:effectLst/>
+        </p:spPr>
+        <p:style>
+          <a:lnRef idx="1">
+            <a:schemeClr val="accent1"/>
+          </a:lnRef>
+          <a:fillRef idx="3">
+            <a:schemeClr val="accent1"/>
+          </a:fillRef>
+          <a:effectRef idx="2">
+            <a:schemeClr val="accent1"/>
+          </a:effectRef>
+          <a:fontRef idx="minor">
+            <a:schemeClr val="lt1"/>
+          </a:fontRef>
+        </p:style>
+        <p:txBody>
+          <a:bodyPr rtlCol="0" anchor="ctr" wrap="square"/>
+          <a:lstStyle/>
+          <a:p>
+            <a:pPr algn="ctr"/>
+            <a:r>
+              <a:rPr sz="1300" b="1">
+                <a:solidFill>
+                  <a:srgbClr val="1F2937"/>
+                </a:solidFill>
+                <a:latin typeface="Calibri"/>
+              </a:rPr>
+              <a:t>run-full-stack-conformance.sh</a:t>
+            </a:r>
+          </a:p>
+          <a:p>
+            <a:pPr algn="ctr"/>
+            <a:r>
+              <a:rPr sz="1100">
+                <a:solidFill>
+                  <a:srgbClr val="5B6573"/>
+                </a:solidFill>
+                <a:latin typeface="Calibri"/>
+              </a:rPr>
+              <a:t>--component certify | verify | --combined</a:t>
+            </a:r>
+          </a:p>
+          <a:p>
+            <a:pPr algn="ctr"/>
+            <a:r>
+              <a:rPr sz="1100">
+                <a:solidFill>
+                  <a:srgbClr val="5B6573"/>
+                </a:solidFill>
+                <a:latin typeface="Calibri"/>
+              </a:rPr>
+              <a:t>--approve-runtime</a:t>
+            </a:r>
+          </a:p>
+        </p:txBody>
+      </p:sp>
+      <p:sp>
+        <p:nvSpPr>
+          <p:cNvPr id="8" name="Rounded Rectangle 7"/>
+          <p:cNvSpPr/>
+          <p:nvPr/>
+        </p:nvSpPr>
+        <p:spPr>
+          <a:xfrm>
+            <a:off x="548640" y="2926080"/>
+            <a:ext cx="2834640" cy="960120"/>
+          </a:xfrm>
+          <a:prstGeom prst="roundRect">
+            <a:avLst>
+              <a:gd name="adj" fmla="val 6000"/>
+            </a:avLst>
+          </a:prstGeom>
+          <a:solidFill>
+            <a:srgbClr val="F3F4F6"/>
+          </a:solidFill>
+          <a:ln w="19050">
+            <a:solidFill>
+              <a:srgbClr val="6B7280"/>
+            </a:solidFill>
+          </a:ln>
+          <a:effectLst/>
+        </p:spPr>
+        <p:style>
+          <a:lnRef idx="1">
+            <a:schemeClr val="accent1"/>
+          </a:lnRef>
+          <a:fillRef idx="3">
+            <a:schemeClr val="accent1"/>
+          </a:fillRef>
+          <a:effectRef idx="2">
+            <a:schemeClr val="accent1"/>
+          </a:effectRef>
+          <a:fontRef idx="minor">
+            <a:schemeClr val="lt1"/>
+          </a:fontRef>
+        </p:style>
+        <p:txBody>
+          <a:bodyPr rtlCol="0" anchor="ctr" wrap="square"/>
+          <a:lstStyle/>
+          <a:p>
+            <a:pPr algn="ctr"/>
+            <a:r>
+              <a:rPr sz="1300" b="1">
+                <a:solidFill>
+                  <a:srgbClr val="1F2937"/>
+                </a:solidFill>
+                <a:latin typeface="Calibri"/>
+              </a:rPr>
+              <a:t>run_combined.py</a:t>
+            </a:r>
+          </a:p>
+          <a:p>
+            <a:pPr algn="ctr"/>
+            <a:r>
+              <a:rPr sz="1100">
+                <a:solidFill>
+                  <a:srgbClr val="5B6573"/>
+                </a:solidFill>
+                <a:latin typeface="Calibri"/>
+              </a:rPr>
+              <a:t>owned lifecycle, selected modules</a:t>
+            </a:r>
+          </a:p>
+          <a:p>
+            <a:pPr algn="ctr"/>
+            <a:r>
+              <a:rPr sz="1100">
+                <a:solidFill>
+                  <a:srgbClr val="5B6573"/>
+                </a:solidFill>
+                <a:latin typeface="Calibri"/>
+              </a:rPr>
+              <a:t>exact cleanup of what it started</a:t>
+            </a:r>
+          </a:p>
+        </p:txBody>
+      </p:sp>
+      <p:sp>
+        <p:nvSpPr>
+          <p:cNvPr id="9" name="Rounded Rectangle 8"/>
+          <p:cNvSpPr/>
+          <p:nvPr/>
+        </p:nvSpPr>
+        <p:spPr>
+          <a:xfrm>
+            <a:off x="548640" y="4069080"/>
+            <a:ext cx="2834640" cy="640080"/>
+          </a:xfrm>
+          <a:prstGeom prst="roundRect">
+            <a:avLst>
+              <a:gd name="adj" fmla="val 6000"/>
+            </a:avLst>
+          </a:prstGeom>
+          <a:solidFill>
+            <a:srgbClr val="F3F4F6"/>
+          </a:solidFill>
+          <a:ln w="19050">
+            <a:solidFill>
+              <a:srgbClr val="6B7280"/>
+            </a:solidFill>
+          </a:ln>
+          <a:effectLst/>
+        </p:spPr>
+        <p:style>
+          <a:lnRef idx="1">
+            <a:schemeClr val="accent1"/>
+          </a:lnRef>
+          <a:fillRef idx="3">
+            <a:schemeClr val="accent1"/>
+          </a:fillRef>
+          <a:effectRef idx="2">
+            <a:schemeClr val="accent1"/>
+          </a:effectRef>
+          <a:fontRef idx="minor">
+            <a:schemeClr val="lt1"/>
+          </a:fontRef>
+        </p:style>
+        <p:txBody>
+          <a:bodyPr rtlCol="0" anchor="ctr" wrap="square"/>
+          <a:lstStyle/>
+          <a:p>
+            <a:pPr algn="ctr"/>
+            <a:r>
+              <a:rPr sz="1300" b="1">
+                <a:solidFill>
+                  <a:srgbClr val="1F2937"/>
+                </a:solidFill>
+                <a:latin typeface="Calibri"/>
+              </a:rPr>
+              <a:t>api-testrig TestNG class per module</a:t>
+            </a:r>
+          </a:p>
+          <a:p>
+            <a:pPr algn="ctr"/>
+            <a:r>
+              <a:rPr sz="1000">
+                <a:solidFill>
+                  <a:srgbClr val="5B6573"/>
+                </a:solidFill>
+                <a:latin typeface="Calibri"/>
+              </a:rPr>
+              <a:t>native Extent + TestNG XML</a:t>
+            </a:r>
+          </a:p>
+        </p:txBody>
+      </p:sp>
+      <p:sp>
+        <p:nvSpPr>
+          <p:cNvPr id="10" name="Rounded Rectangle 9"/>
+          <p:cNvSpPr/>
+          <p:nvPr/>
+        </p:nvSpPr>
+        <p:spPr>
+          <a:xfrm>
+            <a:off x="4297680" y="1783080"/>
+            <a:ext cx="1737360" cy="914400"/>
+          </a:xfrm>
+          <a:prstGeom prst="roundRect">
+            <a:avLst>
+              <a:gd name="adj" fmla="val 6000"/>
+            </a:avLst>
+          </a:prstGeom>
+          <a:solidFill>
+            <a:srgbClr val="E8F1FB"/>
+          </a:solidFill>
+          <a:ln w="19050">
+            <a:solidFill>
+              <a:srgbClr val="3B6EA8"/>
+            </a:solidFill>
+          </a:ln>
+          <a:effectLst/>
+        </p:spPr>
+        <p:style>
+          <a:lnRef idx="1">
+            <a:schemeClr val="accent1"/>
+          </a:lnRef>
+          <a:fillRef idx="3">
+            <a:schemeClr val="accent1"/>
+          </a:fillRef>
+          <a:effectRef idx="2">
+            <a:schemeClr val="accent1"/>
+          </a:effectRef>
+          <a:fontRef idx="minor">
+            <a:schemeClr val="lt1"/>
+          </a:fontRef>
+        </p:style>
+        <p:txBody>
+          <a:bodyPr rtlCol="0" anchor="ctr" wrap="square"/>
+          <a:lstStyle/>
+          <a:p>
+            <a:pPr algn="ctr"/>
+            <a:r>
+              <a:rPr sz="1300" b="1">
+                <a:solidFill>
+                  <a:srgbClr val="1F2937"/>
+                </a:solidFill>
+                <a:latin typeface="Calibri"/>
+              </a:rPr>
+              <a:t>OpenID suite + Mongo</a:t>
+            </a:r>
+          </a:p>
+          <a:p>
+            <a:pPr algn="ctr"/>
+            <a:r>
+              <a:rPr sz="1100">
+                <a:solidFill>
+                  <a:srgbClr val="5B6573"/>
+                </a:solidFill>
+                <a:latin typeface="Calibri"/>
+              </a:rPr>
+              <a:t>official suite, pinned</a:t>
+            </a:r>
+          </a:p>
+        </p:txBody>
+      </p:sp>
+      <p:sp>
+        <p:nvSpPr>
+          <p:cNvPr id="11" name="Rounded Rectangle 10"/>
+          <p:cNvSpPr/>
+          <p:nvPr/>
+        </p:nvSpPr>
+        <p:spPr>
+          <a:xfrm>
+            <a:off x="6217920" y="1783080"/>
+            <a:ext cx="1737360" cy="914400"/>
+          </a:xfrm>
+          <a:prstGeom prst="roundRect">
+            <a:avLst>
+              <a:gd name="adj" fmla="val 6000"/>
+            </a:avLst>
+          </a:prstGeom>
+          <a:solidFill>
+            <a:srgbClr val="FFF4E5"/>
+          </a:solidFill>
+          <a:ln w="19050">
+            <a:solidFill>
+              <a:srgbClr val="C2761A"/>
+            </a:solidFill>
+          </a:ln>
+          <a:effectLst/>
+        </p:spPr>
+        <p:style>
+          <a:lnRef idx="1">
+            <a:schemeClr val="accent1"/>
+          </a:lnRef>
+          <a:fillRef idx="3">
+            <a:schemeClr val="accent1"/>
+          </a:fillRef>
+          <a:effectRef idx="2">
+            <a:schemeClr val="accent1"/>
+          </a:effectRef>
+          <a:fontRef idx="minor">
+            <a:schemeClr val="lt1"/>
+          </a:fontRef>
+        </p:style>
+        <p:txBody>
+          <a:bodyPr rtlCol="0" anchor="ctr" wrap="square"/>
+          <a:lstStyle/>
+          <a:p>
+            <a:pPr algn="ctr"/>
+            <a:r>
+              <a:rPr sz="1300" b="1">
+                <a:solidFill>
+                  <a:srgbClr val="1F2937"/>
+                </a:solidFill>
+                <a:latin typeface="Calibri"/>
+              </a:rPr>
+              <a:t>Inji Certify</a:t>
+            </a:r>
+          </a:p>
+          <a:p>
+            <a:pPr algn="ctr"/>
+            <a:r>
+              <a:rPr sz="1100">
+                <a:solidFill>
+                  <a:srgbClr val="5B6573"/>
+                </a:solidFill>
+                <a:latin typeface="Calibri"/>
+              </a:rPr>
+              <a:t>pinned 8fdf716</a:t>
+            </a:r>
+          </a:p>
+          <a:p>
+            <a:pPr algn="ctr"/>
+            <a:r>
+              <a:rPr sz="1100">
+                <a:solidFill>
+                  <a:srgbClr val="5B6573"/>
+                </a:solidFill>
+                <a:latin typeface="Calibri"/>
+              </a:rPr>
+              <a:t>issuer under test</a:t>
+            </a:r>
+          </a:p>
+        </p:txBody>
+      </p:sp>
+      <p:sp>
+        <p:nvSpPr>
+          <p:cNvPr id="12" name="Rounded Rectangle 11"/>
+          <p:cNvSpPr/>
+          <p:nvPr/>
+        </p:nvSpPr>
+        <p:spPr>
+          <a:xfrm>
+            <a:off x="4297680" y="2880360"/>
+            <a:ext cx="1737360" cy="914400"/>
+          </a:xfrm>
+          <a:prstGeom prst="roundRect">
+            <a:avLst>
+              <a:gd name="adj" fmla="val 6000"/>
+            </a:avLst>
+          </a:prstGeom>
+          <a:solidFill>
+            <a:srgbClr val="FFF4E5"/>
+          </a:solidFill>
+          <a:ln w="19050">
+            <a:solidFill>
+              <a:srgbClr val="C2761A"/>
+            </a:solidFill>
+          </a:ln>
+          <a:effectLst/>
+        </p:spPr>
+        <p:style>
+          <a:lnRef idx="1">
+            <a:schemeClr val="accent1"/>
+          </a:lnRef>
+          <a:fillRef idx="3">
+            <a:schemeClr val="accent1"/>
+          </a:fillRef>
+          <a:effectRef idx="2">
+            <a:schemeClr val="accent1"/>
+          </a:effectRef>
+          <a:fontRef idx="minor">
+            <a:schemeClr val="lt1"/>
+          </a:fontRef>
+        </p:style>
+        <p:txBody>
+          <a:bodyPr rtlCol="0" anchor="ctr" wrap="square"/>
+          <a:lstStyle/>
+          <a:p>
+            <a:pPr algn="ctr"/>
+            <a:r>
+              <a:rPr sz="1300" b="1">
+                <a:solidFill>
+                  <a:srgbClr val="1F2937"/>
+                </a:solidFill>
+                <a:latin typeface="Calibri"/>
+              </a:rPr>
+              <a:t>Inji Verify</a:t>
+            </a:r>
+          </a:p>
+          <a:p>
+            <a:pPr algn="ctr"/>
+            <a:r>
+              <a:rPr sz="1100">
+                <a:solidFill>
+                  <a:srgbClr val="5B6573"/>
+                </a:solidFill>
+                <a:latin typeface="Calibri"/>
+              </a:rPr>
+              <a:t>pinned 4c42890</a:t>
+            </a:r>
+          </a:p>
+          <a:p>
+            <a:pPr algn="ctr"/>
+            <a:r>
+              <a:rPr sz="1100">
+                <a:solidFill>
+                  <a:srgbClr val="5B6573"/>
+                </a:solidFill>
+                <a:latin typeface="Calibri"/>
+              </a:rPr>
+              <a:t>verifier under test</a:t>
+            </a:r>
+          </a:p>
+        </p:txBody>
+      </p:sp>
+      <p:sp>
+        <p:nvSpPr>
+          <p:cNvPr id="13" name="Rounded Rectangle 12"/>
+          <p:cNvSpPr/>
+          <p:nvPr/>
+        </p:nvSpPr>
+        <p:spPr>
+          <a:xfrm>
+            <a:off x="6217920" y="2880360"/>
+            <a:ext cx="1737360" cy="914400"/>
+          </a:xfrm>
+          <a:prstGeom prst="roundRect">
+            <a:avLst>
+              <a:gd name="adj" fmla="val 6000"/>
+            </a:avLst>
+          </a:prstGeom>
+          <a:solidFill>
+            <a:srgbClr val="F3F4F6"/>
+          </a:solidFill>
+          <a:ln w="19050">
+            <a:solidFill>
+              <a:srgbClr val="6B7280"/>
+            </a:solidFill>
+          </a:ln>
+          <a:effectLst/>
+        </p:spPr>
+        <p:style>
+          <a:lnRef idx="1">
+            <a:schemeClr val="accent1"/>
+          </a:lnRef>
+          <a:fillRef idx="3">
+            <a:schemeClr val="accent1"/>
+          </a:fillRef>
+          <a:effectRef idx="2">
+            <a:schemeClr val="accent1"/>
+          </a:effectRef>
+          <a:fontRef idx="minor">
+            <a:schemeClr val="lt1"/>
+          </a:fontRef>
+        </p:style>
+        <p:txBody>
+          <a:bodyPr rtlCol="0" anchor="ctr" wrap="square"/>
+          <a:lstStyle/>
+          <a:p>
+            <a:pPr algn="ctr"/>
+            <a:r>
+              <a:rPr sz="1300" b="1">
+                <a:solidFill>
+                  <a:srgbClr val="1F2937"/>
+                </a:solidFill>
+                <a:latin typeface="Calibri"/>
+              </a:rPr>
+              <a:t>eSignet + mock identity</a:t>
+            </a:r>
+          </a:p>
+          <a:p>
+            <a:pPr algn="ctr"/>
+            <a:r>
+              <a:rPr sz="1100">
+                <a:solidFill>
+                  <a:srgbClr val="5B6573"/>
+                </a:solidFill>
+                <a:latin typeface="Calibri"/>
+              </a:rPr>
+              <a:t>TLS gateway</a:t>
+            </a:r>
+          </a:p>
+        </p:txBody>
+      </p:sp>
+      <p:sp>
+        <p:nvSpPr>
+          <p:cNvPr id="14" name="Rounded Rectangle 13"/>
+          <p:cNvSpPr/>
+          <p:nvPr/>
+        </p:nvSpPr>
+        <p:spPr>
+          <a:xfrm>
+            <a:off x="4297680" y="3977640"/>
+            <a:ext cx="3657600" cy="731520"/>
+          </a:xfrm>
+          <a:prstGeom prst="roundRect">
+            <a:avLst>
+              <a:gd name="adj" fmla="val 6000"/>
+            </a:avLst>
+          </a:prstGeom>
+          <a:solidFill>
+            <a:srgbClr val="EAF6EC"/>
+          </a:solidFill>
+          <a:ln w="19050">
+            <a:solidFill>
+              <a:srgbClr val="3F8F5B"/>
+            </a:solidFill>
+          </a:ln>
+          <a:effectLst/>
+        </p:spPr>
+        <p:style>
+          <a:lnRef idx="1">
+            <a:schemeClr val="accent1"/>
+          </a:lnRef>
+          <a:fillRef idx="3">
+            <a:schemeClr val="accent1"/>
+          </a:fillRef>
+          <a:effectRef idx="2">
+            <a:schemeClr val="accent1"/>
+          </a:effectRef>
+          <a:fontRef idx="minor">
+            <a:schemeClr val="lt1"/>
+          </a:fontRef>
+        </p:style>
+        <p:txBody>
+          <a:bodyPr rtlCol="0" anchor="ctr" wrap="square"/>
+          <a:lstStyle/>
+          <a:p>
+            <a:pPr algn="ctr"/>
+            <a:r>
+              <a:rPr sz="1300" b="1">
+                <a:solidFill>
+                  <a:srgbClr val="1F2937"/>
+                </a:solidFill>
+                <a:latin typeface="Calibri"/>
+              </a:rPr>
+              <a:t>Local MinIO (source-built, pinned)</a:t>
+            </a:r>
+          </a:p>
+          <a:p>
+            <a:pPr algn="ctr"/>
+            <a:r>
+              <a:rPr sz="1100">
+                <a:solidFill>
+                  <a:srgbClr val="5B6573"/>
+                </a:solidFill>
+                <a:latin typeface="Calibri"/>
+              </a:rPr>
+              <a:t>native reports uploaded, hashes read back</a:t>
+            </a:r>
+          </a:p>
+        </p:txBody>
+      </p:sp>
+      <p:sp>
+        <p:nvSpPr>
+          <p:cNvPr id="15" name="Rounded Rectangle 14"/>
+          <p:cNvSpPr/>
+          <p:nvPr/>
+        </p:nvSpPr>
+        <p:spPr>
+          <a:xfrm>
+            <a:off x="8869680" y="1783080"/>
+            <a:ext cx="2773680" cy="640080"/>
+          </a:xfrm>
+          <a:prstGeom prst="roundRect">
+            <a:avLst>
+              <a:gd name="adj" fmla="val 6000"/>
+            </a:avLst>
+          </a:prstGeom>
+          <a:solidFill>
+            <a:srgbClr val="F3F4F6"/>
+          </a:solidFill>
+          <a:ln w="19050">
+            <a:solidFill>
+              <a:srgbClr val="6B7280"/>
+            </a:solidFill>
+          </a:ln>
+          <a:effectLst/>
+        </p:spPr>
+        <p:style>
+          <a:lnRef idx="1">
+            <a:schemeClr val="accent1"/>
+          </a:lnRef>
+          <a:fillRef idx="3">
+            <a:schemeClr val="accent1"/>
+          </a:fillRef>
+          <a:effectRef idx="2">
+            <a:schemeClr val="accent1"/>
+          </a:effectRef>
+          <a:fontRef idx="minor">
+            <a:schemeClr val="lt1"/>
+          </a:fontRef>
+        </p:style>
+        <p:txBody>
+          <a:bodyPr rtlCol="0" anchor="ctr" wrap="square"/>
+          <a:lstStyle/>
+          <a:p>
+            <a:pPr algn="ctr"/>
+            <a:r>
+              <a:rPr sz="1300" b="1">
+                <a:solidFill>
+                  <a:srgbClr val="1F2937"/>
+                </a:solidFill>
+                <a:latin typeface="Calibri"/>
+              </a:rPr>
+              <a:t>combined-results.json</a:t>
+            </a:r>
+          </a:p>
+          <a:p>
+            <a:pPr algn="ctr"/>
+            <a:r>
+              <a:rPr sz="1000">
+                <a:solidFill>
+                  <a:srgbClr val="5B6573"/>
+                </a:solidFill>
+                <a:latin typeface="Calibri"/>
+              </a:rPr>
+              <a:t>status, failed conditions, req ids</a:t>
+            </a:r>
+          </a:p>
+        </p:txBody>
+      </p:sp>
+      <p:sp>
+        <p:nvSpPr>
+          <p:cNvPr id="16" name="Rounded Rectangle 15"/>
+          <p:cNvSpPr/>
+          <p:nvPr/>
+        </p:nvSpPr>
+        <p:spPr>
+          <a:xfrm>
+            <a:off x="8869680" y="2606040"/>
+            <a:ext cx="2773680" cy="640080"/>
+          </a:xfrm>
+          <a:prstGeom prst="roundRect">
+            <a:avLst>
+              <a:gd name="adj" fmla="val 6000"/>
+            </a:avLst>
+          </a:prstGeom>
+          <a:solidFill>
+            <a:srgbClr val="F3F4F6"/>
+          </a:solidFill>
+          <a:ln w="19050">
+            <a:solidFill>
+              <a:srgbClr val="6B7280"/>
+            </a:solidFill>
+          </a:ln>
+          <a:effectLst/>
+        </p:spPr>
+        <p:style>
+          <a:lnRef idx="1">
+            <a:schemeClr val="accent1"/>
+          </a:lnRef>
+          <a:fillRef idx="3">
+            <a:schemeClr val="accent1"/>
+          </a:fillRef>
+          <a:effectRef idx="2">
+            <a:schemeClr val="accent1"/>
+          </a:effectRef>
+          <a:fontRef idx="minor">
+            <a:schemeClr val="lt1"/>
+          </a:fontRef>
+        </p:style>
+        <p:txBody>
+          <a:bodyPr rtlCol="0" anchor="ctr" wrap="square"/>
+          <a:lstStyle/>
+          <a:p>
+            <a:pPr algn="ctr"/>
+            <a:r>
+              <a:rPr sz="1300" b="1">
+                <a:solidFill>
+                  <a:srgbClr val="1F2937"/>
+                </a:solidFill>
+                <a:latin typeface="Calibri"/>
+              </a:rPr>
+              <a:t>native reports + S3 receipt</a:t>
+            </a:r>
+          </a:p>
+          <a:p>
+            <a:pPr algn="ctr"/>
+            <a:r>
+              <a:rPr sz="1000">
+                <a:solidFill>
+                  <a:srgbClr val="5B6573"/>
+                </a:solidFill>
+                <a:latin typeface="Calibri"/>
+              </a:rPr>
+              <a:t>TestNG XML, Extent HTML</a:t>
+            </a:r>
+          </a:p>
+        </p:txBody>
+      </p:sp>
+      <p:sp>
+        <p:nvSpPr>
+          <p:cNvPr id="17" name="Rounded Rectangle 16"/>
+          <p:cNvSpPr/>
+          <p:nvPr/>
+        </p:nvSpPr>
+        <p:spPr>
+          <a:xfrm>
+            <a:off x="8869680" y="3429000"/>
+            <a:ext cx="2773680" cy="640080"/>
+          </a:xfrm>
+          <a:prstGeom prst="roundRect">
+            <a:avLst>
+              <a:gd name="adj" fmla="val 6000"/>
+            </a:avLst>
+          </a:prstGeom>
+          <a:solidFill>
+            <a:srgbClr val="F3F4F6"/>
+          </a:solidFill>
+          <a:ln w="19050">
+            <a:solidFill>
+              <a:srgbClr val="6B7280"/>
+            </a:solidFill>
+          </a:ln>
+          <a:effectLst/>
+        </p:spPr>
+        <p:style>
+          <a:lnRef idx="1">
+            <a:schemeClr val="accent1"/>
+          </a:lnRef>
+          <a:fillRef idx="3">
+            <a:schemeClr val="accent1"/>
+          </a:fillRef>
+          <a:effectRef idx="2">
+            <a:schemeClr val="accent1"/>
+          </a:effectRef>
+          <a:fontRef idx="minor">
+            <a:schemeClr val="lt1"/>
+          </a:fontRef>
+        </p:style>
+        <p:txBody>
+          <a:bodyPr rtlCol="0" anchor="ctr" wrap="square"/>
+          <a:lstStyle/>
+          <a:p>
+            <a:pPr algn="ctr"/>
+            <a:r>
+              <a:rPr sz="1300" b="1">
+                <a:solidFill>
+                  <a:srgbClr val="1F2937"/>
+                </a:solidFill>
+                <a:latin typeface="Calibri"/>
+              </a:rPr>
+              <a:t>cleanup.json (cleanup_verified)</a:t>
+            </a:r>
+          </a:p>
+          <a:p>
+            <a:pPr algn="ctr"/>
+            <a:r>
+              <a:rPr sz="1000">
+                <a:solidFill>
+                  <a:srgbClr val="5B6573"/>
+                </a:solidFill>
+                <a:latin typeface="Calibri"/>
+              </a:rPr>
+              <a:t>hosts restored, nothing left</a:t>
+            </a:r>
+          </a:p>
+        </p:txBody>
+      </p:sp>
+      <p:sp>
+        <p:nvSpPr>
+          <p:cNvPr id="18" name="Rounded Rectangle 17"/>
+          <p:cNvSpPr/>
+          <p:nvPr/>
+        </p:nvSpPr>
+        <p:spPr>
+          <a:xfrm>
+            <a:off x="8869680" y="4251960"/>
+            <a:ext cx="2773680" cy="457200"/>
+          </a:xfrm>
+          <a:prstGeom prst="roundRect">
+            <a:avLst>
+              <a:gd name="adj" fmla="val 6000"/>
+            </a:avLst>
+          </a:prstGeom>
+          <a:solidFill>
+            <a:srgbClr val="F3F4F6"/>
+          </a:solidFill>
+          <a:ln w="19050">
+            <a:solidFill>
+              <a:srgbClr val="6B7280"/>
+            </a:solidFill>
+          </a:ln>
+          <a:effectLst/>
+        </p:spPr>
+        <p:style>
+          <a:lnRef idx="1">
+            <a:schemeClr val="accent1"/>
+          </a:lnRef>
+          <a:fillRef idx="3">
+            <a:schemeClr val="accent1"/>
+          </a:fillRef>
+          <a:effectRef idx="2">
+            <a:schemeClr val="accent1"/>
+          </a:effectRef>
+          <a:fontRef idx="minor">
+            <a:schemeClr val="lt1"/>
+          </a:fontRef>
+        </p:style>
+        <p:txBody>
+          <a:bodyPr rtlCol="0" anchor="ctr" wrap="square"/>
+          <a:lstStyle/>
+          <a:p>
+            <a:pPr algn="ctr"/>
+            <a:r>
+              <a:rPr sz="1300" b="1">
+                <a:solidFill>
+                  <a:srgbClr val="1F2937"/>
+                </a:solidFill>
+                <a:latin typeface="Calibri"/>
+              </a:rPr>
+              <a:t>audit_evidence.py</a:t>
+            </a:r>
+          </a:p>
+          <a:p>
+            <a:pPr algn="ctr"/>
+            <a:r>
+              <a:rPr sz="1000">
+                <a:solidFill>
+                  <a:srgbClr val="5B6573"/>
+                </a:solidFill>
+                <a:latin typeface="Calibri"/>
+              </a:rPr>
+              <a:t>public files only</a:t>
+            </a:r>
+          </a:p>
+        </p:txBody>
+      </p:sp>
+      <p:cxnSp>
+        <p:nvCxnSpPr>
+          <p:cNvPr id="19" name="Connector 18"/>
+          <p:cNvCxnSpPr/>
+          <p:nvPr/>
+        </p:nvCxnSpPr>
+        <p:spPr>
+          <a:xfrm>
+            <a:off x="3566160" y="3108960"/>
+            <a:ext cx="548640" cy="0"/>
+          </a:xfrm>
+          <a:prstGeom prst="line">
+            <a:avLst/>
+          </a:prstGeom>
+          <a:ln w="19050">
+            <a:solidFill>
+              <a:srgbClr val="6B7280"/>
+            </a:solidFill>
+            <a:tailEnd type="triangle"/>
+          </a:ln>
+        </p:spPr>
+        <p:style>
+          <a:lnRef idx="2">
+            <a:schemeClr val="accent1"/>
+          </a:lnRef>
+          <a:fillRef idx="0">
+            <a:schemeClr val="accent1"/>
+          </a:fillRef>
+          <a:effectRef idx="1">
+            <a:schemeClr val="accent1"/>
+          </a:effectRef>
+          <a:fontRef idx="minor">
+            <a:schemeClr val="tx1"/>
+          </a:fontRef>
+        </p:style>
+      </p:cxnSp>
+      <p:cxnSp>
+        <p:nvCxnSpPr>
+          <p:cNvPr id="20" name="Connector 19"/>
+          <p:cNvCxnSpPr/>
+          <p:nvPr/>
+        </p:nvCxnSpPr>
+        <p:spPr>
+          <a:xfrm>
+            <a:off x="8138160" y="3108960"/>
+            <a:ext cx="548640" cy="0"/>
+          </a:xfrm>
+          <a:prstGeom prst="line">
+            <a:avLst/>
+          </a:prstGeom>
+          <a:ln w="19050">
+            <a:solidFill>
+              <a:srgbClr val="6B7280"/>
+            </a:solidFill>
+            <a:tailEnd type="triangle"/>
+          </a:ln>
+        </p:spPr>
+        <p:style>
+          <a:lnRef idx="2">
+            <a:schemeClr val="accent1"/>
+          </a:lnRef>
+          <a:fillRef idx="0">
+            <a:schemeClr val="accent1"/>
+          </a:fillRef>
+          <a:effectRef idx="1">
+            <a:schemeClr val="accent1"/>
+          </a:effectRef>
+          <a:fontRef idx="minor">
+            <a:schemeClr val="tx1"/>
+          </a:fontRef>
+        </p:style>
+      </p:cxnSp>
+      <p:sp>
+        <p:nvSpPr>
+          <p:cNvPr id="21" name="TextBox 20"/>
+          <p:cNvSpPr txBox="1"/>
+          <p:nvPr/>
+        </p:nvSpPr>
+        <p:spPr>
+          <a:xfrm>
+            <a:off x="365760" y="5029200"/>
+            <a:ext cx="11460480" cy="300000"/>
+          </a:xfrm>
+          <a:prstGeom prst="rect">
+            <a:avLst/>
+          </a:prstGeom>
+          <a:noFill/>
+        </p:spPr>
+        <p:txBody>
+          <a:bodyPr wrap="square">
+            <a:spAutoFit/>
+          </a:bodyPr>
+          <a:lstStyle/>
+          <a:p>
+            <a:pPr algn="l"/>
+            <a:r>
+              <a:rPr sz="1200" b="1">
+                <a:solidFill>
+                  <a:srgbClr val="1F2937"/>
+                </a:solidFill>
+                <a:latin typeface="Calibri"/>
+              </a:rPr>
+              <a:t>Recorded outcomes on hosted runners (selected happy flows)</a:t>
+            </a:r>
+          </a:p>
+        </p:txBody>
+      </p:sp>
+      <p:sp>
+        <p:nvSpPr>
+          <p:cNvPr id="22" name="Rounded Rectangle 21"/>
+          <p:cNvSpPr/>
+          <p:nvPr/>
+        </p:nvSpPr>
+        <p:spPr>
+          <a:xfrm>
+            <a:off x="365760" y="5349240"/>
+            <a:ext cx="3749040" cy="914400"/>
+          </a:xfrm>
+          <a:prstGeom prst="roundRect">
+            <a:avLst>
+              <a:gd name="adj" fmla="val 6000"/>
+            </a:avLst>
+          </a:prstGeom>
+          <a:solidFill>
+            <a:srgbClr val="FDECEC"/>
+          </a:solidFill>
+          <a:ln w="19050">
+            <a:solidFill>
+              <a:srgbClr val="B04040"/>
+            </a:solidFill>
+          </a:ln>
+          <a:effectLst/>
+        </p:spPr>
+        <p:style>
+          <a:lnRef idx="1">
+            <a:schemeClr val="accent1"/>
+          </a:lnRef>
+          <a:fillRef idx="3">
+            <a:schemeClr val="accent1"/>
+          </a:fillRef>
+          <a:effectRef idx="2">
+            <a:schemeClr val="accent1"/>
+          </a:effectRef>
+          <a:fontRef idx="minor">
+            <a:schemeClr val="lt1"/>
+          </a:fontRef>
+        </p:style>
+        <p:txBody>
+          <a:bodyPr rtlCol="0" anchor="ctr" wrap="square"/>
+          <a:lstStyle/>
+          <a:p>
+            <a:pPr algn="ctr"/>
+            <a:r>
+              <a:rPr sz="1200" b="1">
+                <a:solidFill>
+                  <a:srgbClr val="1F2937"/>
+                </a:solidFill>
+                <a:latin typeface="Calibri"/>
+              </a:rPr>
+              <a:t>Certify: module FAILED</a:t>
+            </a:r>
+          </a:p>
+          <a:p>
+            <a:pPr algn="ctr"/>
+            <a:r>
+              <a:rPr sz="1000">
+                <a:solidFill>
+                  <a:srgbClr val="5B6573"/>
+                </a:solidFill>
+                <a:latin typeface="Calibri"/>
+              </a:rPr>
+              <a:t>suite check EnsureHttpStatusCodeIsAnyOf (OID4VCI-1FINAL-8.3)</a:t>
+            </a:r>
+          </a:p>
+          <a:p>
+            <a:pPr algn="ctr"/>
+            <a:r>
+              <a:rPr sz="1000">
+                <a:solidFill>
+                  <a:srgbClr val="5B6573"/>
+                </a:solidFill>
+                <a:latin typeface="Calibri"/>
+              </a:rPr>
+              <a:t>root cause not established</a:t>
+            </a:r>
+          </a:p>
+        </p:txBody>
+      </p:sp>
+      <p:sp>
+        <p:nvSpPr>
+          <p:cNvPr id="23" name="Rounded Rectangle 22"/>
+          <p:cNvSpPr/>
+          <p:nvPr/>
+        </p:nvSpPr>
+        <p:spPr>
+          <a:xfrm>
+            <a:off x="4251960" y="5349240"/>
+            <a:ext cx="3749040" cy="914400"/>
+          </a:xfrm>
+          <a:prstGeom prst="roundRect">
+            <a:avLst>
+              <a:gd name="adj" fmla="val 6000"/>
+            </a:avLst>
+          </a:prstGeom>
+          <a:solidFill>
+            <a:srgbClr val="FFF4E5"/>
+          </a:solidFill>
+          <a:ln w="19050">
+            <a:solidFill>
+              <a:srgbClr val="C2761A"/>
+            </a:solidFill>
+          </a:ln>
+          <a:effectLst/>
+        </p:spPr>
+        <p:style>
+          <a:lnRef idx="1">
+            <a:schemeClr val="accent1"/>
+          </a:lnRef>
+          <a:fillRef idx="3">
+            <a:schemeClr val="accent1"/>
+          </a:fillRef>
+          <a:effectRef idx="2">
+            <a:schemeClr val="accent1"/>
+          </a:effectRef>
+          <a:fontRef idx="minor">
+            <a:schemeClr val="lt1"/>
+          </a:fontRef>
+        </p:style>
+        <p:txBody>
+          <a:bodyPr rtlCol="0" anchor="ctr" wrap="square"/>
+          <a:lstStyle/>
+          <a:p>
+            <a:pPr algn="ctr"/>
+            <a:r>
+              <a:rPr sz="1200" b="1">
+                <a:solidFill>
+                  <a:srgbClr val="1F2937"/>
+                </a:solidFill>
+                <a:latin typeface="Calibri"/>
+              </a:rPr>
+              <a:t>Verify: REVIEW</a:t>
+            </a:r>
+          </a:p>
+          <a:p>
+            <a:pPr algn="ctr"/>
+            <a:r>
+              <a:rPr sz="1000">
+                <a:solidFill>
+                  <a:srgbClr val="5B6573"/>
+                </a:solidFill>
+                <a:latin typeface="Calibri"/>
+              </a:rPr>
+              <a:t>needs a human decision (revocation list WARNING)</a:t>
+            </a:r>
+          </a:p>
+          <a:p>
+            <a:pPr algn="ctr"/>
+            <a:r>
+              <a:rPr sz="1000">
+                <a:solidFill>
+                  <a:srgbClr val="5B6573"/>
+                </a:solidFill>
+                <a:latin typeface="Calibri"/>
+              </a:rPr>
+              <a:t>project PNG is not native Verify UI</a:t>
+            </a:r>
+          </a:p>
+        </p:txBody>
+      </p:sp>
+      <p:sp>
+        <p:nvSpPr>
+          <p:cNvPr id="24" name="Rounded Rectangle 23"/>
+          <p:cNvSpPr/>
+          <p:nvPr/>
+        </p:nvSpPr>
+        <p:spPr>
+          <a:xfrm>
+            <a:off x="8138160" y="5349240"/>
+            <a:ext cx="3688080" cy="914400"/>
+          </a:xfrm>
+          <a:prstGeom prst="roundRect">
+            <a:avLst>
+              <a:gd name="adj" fmla="val 6000"/>
+            </a:avLst>
+          </a:prstGeom>
+          <a:solidFill>
+            <a:srgbClr val="F3F4F6"/>
+          </a:solidFill>
+          <a:ln w="19050">
+            <a:solidFill>
+              <a:srgbClr val="6B7280"/>
+            </a:solidFill>
+          </a:ln>
+          <a:effectLst/>
+        </p:spPr>
+        <p:style>
+          <a:lnRef idx="1">
+            <a:schemeClr val="accent1"/>
+          </a:lnRef>
+          <a:fillRef idx="3">
+            <a:schemeClr val="accent1"/>
+          </a:fillRef>
+          <a:effectRef idx="2">
+            <a:schemeClr val="accent1"/>
+          </a:effectRef>
+          <a:fontRef idx="minor">
+            <a:schemeClr val="lt1"/>
+          </a:fontRef>
+        </p:style>
+        <p:txBody>
+          <a:bodyPr rtlCol="0" anchor="ctr" wrap="square"/>
+          <a:lstStyle/>
+          <a:p>
+            <a:pPr algn="ctr"/>
+            <a:r>
+              <a:rPr sz="1200" b="1">
+                <a:solidFill>
+                  <a:srgbClr val="1F2937"/>
+                </a:solidFill>
+                <a:latin typeface="Calibri"/>
+              </a:rPr>
+              <a:t>Not run on hosted</a:t>
+            </a:r>
+          </a:p>
+          <a:p>
+            <a:pPr algn="ctr"/>
+            <a:r>
+              <a:rPr sz="1000">
+                <a:solidFill>
+                  <a:srgbClr val="5B6573"/>
+                </a:solidFill>
+                <a:latin typeface="Calibri"/>
+              </a:rPr>
+              <a:t>Verify-only via script, full official plans,</a:t>
+            </a:r>
+          </a:p>
+          <a:p>
+            <a:pPr algn="ctr"/>
+            <a:r>
+              <a:rPr sz="1000">
+                <a:solidFill>
+                  <a:srgbClr val="5B6573"/>
+                </a:solidFill>
+                <a:latin typeface="Calibri"/>
+              </a:rPr>
+              <a:t>expected-failure baseline</a:t>
+            </a:r>
+          </a:p>
+        </p:txBody>
+      </p:sp>
+      <p:sp>
+        <p:nvSpPr>
+          <p:cNvPr id="25" name="TextBox 24"/>
+          <p:cNvSpPr txBox="1"/>
+          <p:nvPr/>
+        </p:nvSpPr>
+        <p:spPr>
+          <a:xfrm>
+            <a:off x="365760" y="6355080"/>
+            <a:ext cx="11460480" cy="300000"/>
+          </a:xfrm>
+          <a:prstGeom prst="rect">
+            <a:avLst/>
+          </a:prstGeom>
+          <a:noFill/>
+        </p:spPr>
+        <p:txBody>
+          <a:bodyPr wrap="square">
+            <a:spAutoFit/>
+          </a:bodyPr>
+          <a:lstStyle/>
+          <a:p>
+            <a:pPr algn="l"/>
+            <a:r>
+              <a:rPr sz="1000" b="0">
+                <a:solidFill>
+                  <a:srgbClr val="5B6573"/>
+                </a:solidFill>
+                <a:latin typeface="Calibri"/>
+              </a:rPr>
+              <a:t>Certify-only through the one-command script: proven end to end. Combined Certify + Verify: proven via the phased workflow.</a:t>
             </a:r>
           </a:p>
         </p:txBody>

</xml_diff>